<commit_message>
fix(report): render the Suricatoos logo correctly across PDF/DOCX/PPTX
The meerkat-S mark is too intricate for react-pdf's SVG renderer (it rendered
muddy) and is unreadable when shrunk raw. Pre-rasterize the logo to a clean PNG
inside a white rounded badge that reads well on both dark and light backgrounds,
and embed that image on every cover/header (PDF, DOCX, PPTX). Whitelabel uploads
still override via Branding.appLogo / appLogoOnDark.

Co-Authored-By: Claude Opus 4.8 <noreply@anthropic.com>
</commit_message>
<xml_diff>
--- a/docs/sample-reports/suricatoos-relatorio-ptes.pptx
+++ b/docs/sample-reports/suricatoos-relatorio-ptes.pptx
@@ -1841,16 +1841,40 @@
           <a:ln/>
         </p:spPr>
       </p:sp>
+      <p:pic>
+        <p:nvPicPr>
+          <p:cNvPr id="3" name="Image 0" descr="preencoded.png">    </p:cNvPr>
+          <p:cNvPicPr>
+            <a:picLocks noChangeAspect="1"/>
+          </p:cNvPicPr>
+          <p:nvPr/>
+        </p:nvPicPr>
+        <p:blipFill>
+          <a:blip r:embed="rId1"/>
+          <a:stretch>
+            <a:fillRect/>
+          </a:stretch>
+        </p:blipFill>
+        <p:spPr>
+          <a:xfrm>
+            <a:off x="731520" y="512064"/>
+            <a:ext cx="658368" cy="658368"/>
+          </a:xfrm>
+          <a:prstGeom prst="rect">
+            <a:avLst/>
+          </a:prstGeom>
+        </p:spPr>
+      </p:pic>
       <p:sp>
         <p:nvSpPr>
-          <p:cNvPr id="3" name="Text 1"/>
+          <p:cNvPr id="4" name="Text 1"/>
           <p:cNvSpPr/>
           <p:nvPr/>
         </p:nvSpPr>
         <p:spPr>
           <a:xfrm>
-            <a:off x="731520" y="640080"/>
-            <a:ext cx="7315200" cy="548640"/>
+            <a:off x="1508760" y="512064"/>
+            <a:ext cx="7315200" cy="658368"/>
           </a:xfrm>
           <a:prstGeom prst="rect">
             <a:avLst/>
@@ -1879,7 +1903,7 @@
       </p:sp>
       <p:sp>
         <p:nvSpPr>
-          <p:cNvPr id="4" name="Text 2"/>
+          <p:cNvPr id="5" name="Text 2"/>
           <p:cNvSpPr/>
           <p:nvPr/>
         </p:nvSpPr>
@@ -1915,7 +1939,7 @@
       </p:sp>
       <p:sp>
         <p:nvSpPr>
-          <p:cNvPr id="5" name="Text 3"/>
+          <p:cNvPr id="6" name="Text 3"/>
           <p:cNvSpPr/>
           <p:nvPr/>
         </p:nvSpPr>
@@ -1951,7 +1975,7 @@
       </p:sp>
       <p:sp>
         <p:nvSpPr>
-          <p:cNvPr id="6" name="Text 4"/>
+          <p:cNvPr id="7" name="Text 4"/>
           <p:cNvSpPr/>
           <p:nvPr/>
         </p:nvSpPr>
@@ -1987,7 +2011,7 @@
       </p:sp>
       <p:sp>
         <p:nvSpPr>
-          <p:cNvPr id="7" name="Shape 5"/>
+          <p:cNvPr id="8" name="Shape 5"/>
           <p:cNvSpPr/>
           <p:nvPr/>
         </p:nvSpPr>
@@ -2009,7 +2033,7 @@
       </p:sp>
       <p:sp>
         <p:nvSpPr>
-          <p:cNvPr id="8" name="Text 6"/>
+          <p:cNvPr id="9" name="Text 6"/>
           <p:cNvSpPr/>
           <p:nvPr/>
         </p:nvSpPr>
@@ -2045,7 +2069,7 @@
       </p:sp>
       <p:sp>
         <p:nvSpPr>
-          <p:cNvPr id="9" name="Text 7"/>
+          <p:cNvPr id="10" name="Text 7"/>
           <p:cNvSpPr/>
           <p:nvPr/>
         </p:nvSpPr>
@@ -2081,7 +2105,7 @@
       </p:sp>
       <p:sp>
         <p:nvSpPr>
-          <p:cNvPr id="10" name="Text 8"/>
+          <p:cNvPr id="11" name="Text 8"/>
           <p:cNvSpPr/>
           <p:nvPr/>
         </p:nvSpPr>
@@ -2121,7 +2145,7 @@
       </p:sp>
       <p:sp>
         <p:nvSpPr>
-          <p:cNvPr id="11" name="Text 9"/>
+          <p:cNvPr id="12" name="Text 9"/>
           <p:cNvSpPr/>
           <p:nvPr/>
         </p:nvSpPr>

</xml_diff>